<commit_message>
Refine style sample from additional template photos
Stepped bottom line, title-slide icon tiles and top strip, glass panel in
the background, indicator repositioned, push transitions on all slides.

Co-Authored-By: Claude Opus 5.5 <noreply@anthropic.com>
Claude-Session: https://claude.ai/code/session_01Wi8xFZHPzUxcxh37ABRJpP
</commit_message>
<xml_diff>
--- a/cementing_2025_2026/output/style_sample.pptx
+++ b/cementing_2025_2026/output/style_sample.pptx
@@ -1623,7 +1623,36 @@
         </p:nvSpPr>
         <p:spPr>
           <a:xfrm>
-            <a:off x="10287000" y="1170432"/>
+            <a:off x="777240" y="1033272"/>
+            <a:ext cx="10607040" cy="384048"/>
+          </a:xfrm>
+          <a:prstGeom prst="roundRect">
+            <a:avLst>
+              <a:gd name="adj" fmla="val 50000"/>
+            </a:avLst>
+          </a:prstGeom>
+          <a:solidFill>
+            <a:srgbClr val="FFFFFF">
+              <a:alpha val="55000"/>
+            </a:srgbClr>
+          </a:solidFill>
+          <a:ln w="9525">
+            <a:solidFill>
+              <a:srgbClr val="FFFFFF"/>
+            </a:solidFill>
+            <a:prstDash val="solid"/>
+          </a:ln>
+        </p:spPr>
+      </p:sp>
+      <p:sp>
+        <p:nvSpPr>
+          <p:cNvPr id="6" name="Shape 4"/>
+          <p:cNvSpPr/>
+          <p:nvPr/>
+        </p:nvSpPr>
+        <p:spPr>
+          <a:xfrm>
+            <a:off x="9921240" y="1179576"/>
             <a:ext cx="100584" cy="100584"/>
           </a:xfrm>
           <a:prstGeom prst="ellipse">
@@ -1642,13 +1671,13 @@
       </p:sp>
       <p:sp>
         <p:nvSpPr>
-          <p:cNvPr id="6" name="Shape 4"/>
+          <p:cNvPr id="7" name="Shape 5"/>
           <p:cNvSpPr/>
           <p:nvPr/>
         </p:nvSpPr>
         <p:spPr>
           <a:xfrm>
-            <a:off x="10460736" y="1170432"/>
+            <a:off x="10094976" y="1179576"/>
             <a:ext cx="347472" cy="100584"/>
           </a:xfrm>
           <a:prstGeom prst="roundRect">
@@ -1669,13 +1698,13 @@
       </p:sp>
       <p:sp>
         <p:nvSpPr>
-          <p:cNvPr id="7" name="Shape 5"/>
+          <p:cNvPr id="8" name="Shape 6"/>
           <p:cNvSpPr/>
           <p:nvPr/>
         </p:nvSpPr>
         <p:spPr>
           <a:xfrm>
-            <a:off x="10881360" y="1170432"/>
+            <a:off x="10515600" y="1179576"/>
             <a:ext cx="777240" cy="100584"/>
           </a:xfrm>
           <a:prstGeom prst="roundRect">
@@ -1696,7 +1725,7 @@
       </p:sp>
       <p:sp>
         <p:nvSpPr>
-          <p:cNvPr id="8" name="Shape 6"/>
+          <p:cNvPr id="9" name="Shape 7"/>
           <p:cNvSpPr/>
           <p:nvPr/>
         </p:nvSpPr>
@@ -1719,7 +1748,7 @@
       </p:sp>
       <p:sp>
         <p:nvSpPr>
-          <p:cNvPr id="9" name="Shape 7"/>
+          <p:cNvPr id="10" name="Shape 8"/>
           <p:cNvSpPr/>
           <p:nvPr/>
         </p:nvSpPr>
@@ -1744,7 +1773,7 @@
       </p:sp>
       <p:sp>
         <p:nvSpPr>
-          <p:cNvPr id="10" name="Shape 8"/>
+          <p:cNvPr id="11" name="Shape 9"/>
           <p:cNvSpPr/>
           <p:nvPr/>
         </p:nvSpPr>
@@ -1769,7 +1798,7 @@
       </p:sp>
       <p:sp>
         <p:nvSpPr>
-          <p:cNvPr id="11" name="Shape 9"/>
+          <p:cNvPr id="12" name="Shape 10"/>
           <p:cNvSpPr/>
           <p:nvPr/>
         </p:nvSpPr>
@@ -1794,7 +1823,7 @@
       </p:sp>
       <p:sp>
         <p:nvSpPr>
-          <p:cNvPr id="12" name="Shape 10"/>
+          <p:cNvPr id="13" name="Shape 11"/>
           <p:cNvSpPr/>
           <p:nvPr/>
         </p:nvSpPr>
@@ -1819,7 +1848,7 @@
       </p:sp>
       <p:sp>
         <p:nvSpPr>
-          <p:cNvPr id="13" name="Shape 11"/>
+          <p:cNvPr id="14" name="Shape 12"/>
           <p:cNvSpPr/>
           <p:nvPr/>
         </p:nvSpPr>
@@ -1844,7 +1873,7 @@
       </p:sp>
       <p:sp>
         <p:nvSpPr>
-          <p:cNvPr id="14" name="Shape 12"/>
+          <p:cNvPr id="15" name="Shape 13"/>
           <p:cNvSpPr/>
           <p:nvPr/>
         </p:nvSpPr>
@@ -1869,7 +1898,7 @@
       </p:sp>
       <p:sp>
         <p:nvSpPr>
-          <p:cNvPr id="15" name="Shape 13"/>
+          <p:cNvPr id="16" name="Shape 14"/>
           <p:cNvSpPr/>
           <p:nvPr/>
         </p:nvSpPr>
@@ -1892,7 +1921,7 @@
       </p:sp>
       <p:sp>
         <p:nvSpPr>
-          <p:cNvPr id="16" name="Shape 14"/>
+          <p:cNvPr id="17" name="Shape 15"/>
           <p:cNvSpPr/>
           <p:nvPr/>
         </p:nvSpPr>
@@ -1915,7 +1944,7 @@
       </p:sp>
       <p:sp>
         <p:nvSpPr>
-          <p:cNvPr id="17" name="Text 15"/>
+          <p:cNvPr id="18" name="Text 16"/>
           <p:cNvSpPr txBox="1"/>
           <p:nvPr/>
         </p:nvSpPr>
@@ -1954,7 +1983,7 @@
       </p:sp>
       <p:sp>
         <p:nvSpPr>
-          <p:cNvPr id="18" name="Text 16"/>
+          <p:cNvPr id="19" name="Text 17"/>
           <p:cNvSpPr txBox="1"/>
           <p:nvPr/>
         </p:nvSpPr>
@@ -1993,7 +2022,7 @@
       </p:sp>
       <p:sp>
         <p:nvSpPr>
-          <p:cNvPr id="19" name="Text 17"/>
+          <p:cNvPr id="20" name="Text 18"/>
           <p:cNvSpPr txBox="1"/>
           <p:nvPr/>
         </p:nvSpPr>
@@ -2032,7 +2061,7 @@
       </p:sp>
       <p:sp>
         <p:nvSpPr>
-          <p:cNvPr id="20" name="Text 18"/>
+          <p:cNvPr id="21" name="Text 19"/>
           <p:cNvSpPr txBox="1"/>
           <p:nvPr/>
         </p:nvSpPr>
@@ -2071,7 +2100,7 @@
       </p:sp>
       <p:sp>
         <p:nvSpPr>
-          <p:cNvPr id="21" name="Text 19"/>
+          <p:cNvPr id="22" name="Text 20"/>
           <p:cNvSpPr txBox="1"/>
           <p:nvPr/>
         </p:nvSpPr>
@@ -2110,14 +2139,14 @@
       </p:sp>
       <p:sp>
         <p:nvSpPr>
-          <p:cNvPr id="22" name="Text 20"/>
+          <p:cNvPr id="23" name="Text 21"/>
           <p:cNvSpPr txBox="1"/>
           <p:nvPr/>
         </p:nvSpPr>
         <p:spPr>
           <a:xfrm>
-            <a:off x="5120640" y="1965960"/>
-            <a:ext cx="6217920" cy="274320"/>
+            <a:off x="4846320" y="2103120"/>
+            <a:ext cx="4937760" cy="274320"/>
           </a:xfrm>
           <a:prstGeom prst="rect">
             <a:avLst/>
@@ -2129,11 +2158,11 @@
           <a:bodyPr wrap="square" lIns="0" tIns="0" rIns="0" bIns="0" rtlCol="0" anchor="ctr"/>
           <a:lstStyle/>
           <a:p>
-            <a:pPr indent="0" marL="0">
+            <a:pPr algn="ctr" indent="0" marL="0">
               <a:buNone/>
             </a:pPr>
             <a:r>
-              <a:rPr lang="en-US" sz="1200" spc="150" kern="0" dirty="0">
+              <a:rPr lang="en-US" sz="1100" spc="150" kern="0" dirty="0">
                 <a:solidFill>
                   <a:srgbClr val="6B7280"/>
                 </a:solidFill>
@@ -2143,20 +2172,20 @@
               </a:rPr>
               <a:t>ИНЖЕНЕРНЫЙ АНАЛИЗ · АКЦ · ВПЦ · SRTi</a:t>
             </a:r>
-            <a:endParaRPr lang="en-US" sz="1200" dirty="0"/>
+            <a:endParaRPr lang="en-US" sz="1100" dirty="0"/>
           </a:p>
         </p:txBody>
       </p:sp>
       <p:sp>
         <p:nvSpPr>
-          <p:cNvPr id="23" name="Text 21"/>
+          <p:cNvPr id="24" name="Text 22"/>
           <p:cNvSpPr txBox="1"/>
           <p:nvPr/>
         </p:nvSpPr>
         <p:spPr>
           <a:xfrm>
-            <a:off x="5120640" y="2331720"/>
-            <a:ext cx="6309360" cy="1417320"/>
+            <a:off x="4846320" y="2468880"/>
+            <a:ext cx="4937760" cy="1188720"/>
           </a:xfrm>
           <a:prstGeom prst="rect">
             <a:avLst/>
@@ -2168,14 +2197,14 @@
           <a:bodyPr wrap="square" lIns="0" tIns="0" rIns="0" bIns="0" rtlCol="0" anchor="ctr"/>
           <a:lstStyle/>
           <a:p>
-            <a:pPr indent="0" marL="0">
+            <a:pPr algn="ctr" indent="0" marL="0">
               <a:lnSpc>
-                <a:spcPct val="90000"/>
+                <a:spcPct val="92000"/>
               </a:lnSpc>
               <a:buNone/>
             </a:pPr>
             <a:r>
-              <a:rPr lang="en-US" sz="4000" dirty="0">
+              <a:rPr lang="en-US" sz="3200" dirty="0">
                 <a:solidFill>
                   <a:srgbClr val="3F8A3A"/>
                 </a:solidFill>
@@ -2185,17 +2214,17 @@
               </a:rPr>
               <a:t>КАЧЕСТВО</a:t>
             </a:r>
-            <a:endParaRPr lang="en-US" sz="4000" dirty="0"/>
-          </a:p>
-          <a:p>
-            <a:pPr indent="0" marL="0">
+            <a:endParaRPr lang="en-US" sz="3200" dirty="0"/>
+          </a:p>
+          <a:p>
+            <a:pPr algn="ctr" indent="0" marL="0">
               <a:lnSpc>
-                <a:spcPct val="90000"/>
+                <a:spcPct val="92000"/>
               </a:lnSpc>
               <a:buNone/>
             </a:pPr>
             <a:r>
-              <a:rPr lang="en-US" sz="4000" dirty="0">
+              <a:rPr lang="en-US" sz="3200" dirty="0">
                 <a:solidFill>
                   <a:srgbClr val="3F8A3A"/>
                 </a:solidFill>
@@ -2205,20 +2234,20 @@
               </a:rPr>
               <a:t>ЦЕМЕНТИРОВАНИЯ</a:t>
             </a:r>
-            <a:endParaRPr lang="en-US" sz="4000" dirty="0"/>
+            <a:endParaRPr lang="en-US" sz="3200" dirty="0"/>
           </a:p>
         </p:txBody>
       </p:sp>
       <p:sp>
         <p:nvSpPr>
-          <p:cNvPr id="24" name="Text 22"/>
+          <p:cNvPr id="25" name="Text 23"/>
           <p:cNvSpPr txBox="1"/>
           <p:nvPr/>
         </p:nvSpPr>
         <p:spPr>
           <a:xfrm>
-            <a:off x="5120640" y="3749040"/>
-            <a:ext cx="6309360" cy="548640"/>
+            <a:off x="4846320" y="3657600"/>
+            <a:ext cx="4937760" cy="502920"/>
           </a:xfrm>
           <a:prstGeom prst="rect">
             <a:avLst/>
@@ -2230,11 +2259,11 @@
           <a:bodyPr wrap="square" lIns="0" tIns="0" rIns="0" bIns="0" rtlCol="0" anchor="ctr"/>
           <a:lstStyle/>
           <a:p>
-            <a:pPr indent="0" marL="0">
+            <a:pPr algn="ctr" indent="0" marL="0">
               <a:buNone/>
             </a:pPr>
             <a:r>
-              <a:rPr lang="en-US" sz="2600" dirty="0">
+              <a:rPr lang="en-US" sz="2100" dirty="0">
                 <a:solidFill>
                   <a:srgbClr val="2F5FA6"/>
                 </a:solidFill>
@@ -2244,20 +2273,20 @@
               </a:rPr>
               <a:t>обсадных колонн: 2025 → 2026</a:t>
             </a:r>
-            <a:endParaRPr lang="en-US" sz="2600" dirty="0"/>
+            <a:endParaRPr lang="en-US" sz="2100" dirty="0"/>
           </a:p>
         </p:txBody>
       </p:sp>
       <p:sp>
         <p:nvSpPr>
-          <p:cNvPr id="25" name="Shape 23"/>
+          <p:cNvPr id="26" name="Shape 24"/>
           <p:cNvSpPr/>
           <p:nvPr/>
         </p:nvSpPr>
         <p:spPr>
           <a:xfrm>
-            <a:off x="5120640" y="4617720"/>
-            <a:ext cx="3017520" cy="566928"/>
+            <a:off x="5897880" y="4572000"/>
+            <a:ext cx="2834640" cy="566928"/>
           </a:xfrm>
           <a:prstGeom prst="roundRect">
             <a:avLst>
@@ -2284,14 +2313,14 @@
       </p:sp>
       <p:sp>
         <p:nvSpPr>
-          <p:cNvPr id="26" name="Text 24"/>
+          <p:cNvPr id="27" name="Text 25"/>
           <p:cNvSpPr txBox="1"/>
           <p:nvPr/>
         </p:nvSpPr>
         <p:spPr>
           <a:xfrm>
-            <a:off x="5120640" y="4617720"/>
-            <a:ext cx="3017520" cy="566928"/>
+            <a:off x="5897880" y="4572000"/>
+            <a:ext cx="2834640" cy="566928"/>
           </a:xfrm>
           <a:prstGeom prst="rect">
             <a:avLst/>
@@ -2321,9 +2350,70 @@
           </a:p>
         </p:txBody>
       </p:sp>
+      <p:sp>
+        <p:nvSpPr>
+          <p:cNvPr id="28" name="Shape 26"/>
+          <p:cNvSpPr/>
+          <p:nvPr/>
+        </p:nvSpPr>
+        <p:spPr>
+          <a:xfrm>
+            <a:off x="10012680" y="1783080"/>
+            <a:ext cx="1325880" cy="1463040"/>
+          </a:xfrm>
+          <a:prstGeom prst="roundRect">
+            <a:avLst>
+              <a:gd name="adj" fmla="val 19310"/>
+            </a:avLst>
+          </a:prstGeom>
+          <a:solidFill>
+            <a:srgbClr val="FFFFFF">
+              <a:alpha val="90000"/>
+            </a:srgbClr>
+          </a:solidFill>
+          <a:ln w="12700">
+            <a:solidFill>
+              <a:srgbClr val="FFFFFF"/>
+            </a:solidFill>
+            <a:prstDash val="solid"/>
+          </a:ln>
+          <a:effectLst>
+            <a:outerShdw sx="100000" sy="100000" kx="0" ky="0" algn="bl" rotWithShape="0" blurRad="127000" dist="38100" dir="5400000">
+              <a:srgbClr val="1D3F7A">
+                <a:alpha val="10000"/>
+              </a:srgbClr>
+            </a:outerShdw>
+          </a:effectLst>
+        </p:spPr>
+      </p:sp>
+      <p:sp>
+        <p:nvSpPr>
+          <p:cNvPr id="29" name="Shape 27"/>
+          <p:cNvSpPr/>
+          <p:nvPr/>
+        </p:nvSpPr>
+        <p:spPr>
+          <a:xfrm>
+            <a:off x="10158984" y="1929384"/>
+            <a:ext cx="91440" cy="91440"/>
+          </a:xfrm>
+          <a:prstGeom prst="ellipse">
+            <a:avLst/>
+          </a:prstGeom>
+          <a:solidFill>
+            <a:srgbClr val="4F9D46"/>
+          </a:solidFill>
+          <a:ln w="12700">
+            <a:solidFill>
+              <a:srgbClr val="4F9D46"/>
+            </a:solidFill>
+            <a:prstDash val="solid"/>
+          </a:ln>
+        </p:spPr>
+      </p:sp>
       <p:pic>
         <p:nvPicPr>
-          <p:cNvPr id="27" name="Image 0" descr="/tmp/claude-0/-home-user-nestro/911a244d-2256-5cb1-aca9-58afdd2ea567/scratchpad/build/assets/gradline.png">    </p:cNvPr>
+          <p:cNvPr id="30" name="Image 0" descr="preencoded.png">    </p:cNvPr>
           <p:cNvPicPr>
             <a:picLocks noChangeAspect="1"/>
           </p:cNvPicPr>
@@ -2337,6 +2427,115 @@
         </p:blipFill>
         <p:spPr>
           <a:xfrm>
+            <a:off x="10311003" y="2195703"/>
+            <a:ext cx="729234" cy="729234"/>
+          </a:xfrm>
+          <a:prstGeom prst="rect">
+            <a:avLst/>
+          </a:prstGeom>
+        </p:spPr>
+      </p:pic>
+      <p:sp>
+        <p:nvSpPr>
+          <p:cNvPr id="31" name="Shape 28"/>
+          <p:cNvSpPr/>
+          <p:nvPr/>
+        </p:nvSpPr>
+        <p:spPr>
+          <a:xfrm>
+            <a:off x="10012680" y="3429000"/>
+            <a:ext cx="1325880" cy="1463040"/>
+          </a:xfrm>
+          <a:prstGeom prst="roundRect">
+            <a:avLst>
+              <a:gd name="adj" fmla="val 19310"/>
+            </a:avLst>
+          </a:prstGeom>
+          <a:solidFill>
+            <a:srgbClr val="FFFFFF">
+              <a:alpha val="90000"/>
+            </a:srgbClr>
+          </a:solidFill>
+          <a:ln w="12700">
+            <a:solidFill>
+              <a:srgbClr val="FFFFFF"/>
+            </a:solidFill>
+            <a:prstDash val="solid"/>
+          </a:ln>
+          <a:effectLst>
+            <a:outerShdw sx="100000" sy="100000" kx="0" ky="0" algn="bl" rotWithShape="0" blurRad="127000" dist="38100" dir="5400000">
+              <a:srgbClr val="1D3F7A">
+                <a:alpha val="10000"/>
+              </a:srgbClr>
+            </a:outerShdw>
+          </a:effectLst>
+        </p:spPr>
+      </p:sp>
+      <p:sp>
+        <p:nvSpPr>
+          <p:cNvPr id="32" name="Shape 29"/>
+          <p:cNvSpPr/>
+          <p:nvPr/>
+        </p:nvSpPr>
+        <p:spPr>
+          <a:xfrm>
+            <a:off x="10158984" y="3575304"/>
+            <a:ext cx="91440" cy="91440"/>
+          </a:xfrm>
+          <a:prstGeom prst="ellipse">
+            <a:avLst/>
+          </a:prstGeom>
+          <a:solidFill>
+            <a:srgbClr val="4F9D46"/>
+          </a:solidFill>
+          <a:ln w="12700">
+            <a:solidFill>
+              <a:srgbClr val="4F9D46"/>
+            </a:solidFill>
+            <a:prstDash val="solid"/>
+          </a:ln>
+        </p:spPr>
+      </p:sp>
+      <p:pic>
+        <p:nvPicPr>
+          <p:cNvPr id="33" name="Image 1" descr="preencoded.png">    </p:cNvPr>
+          <p:cNvPicPr>
+            <a:picLocks noChangeAspect="1"/>
+          </p:cNvPicPr>
+          <p:nvPr/>
+        </p:nvPicPr>
+        <p:blipFill>
+          <a:blip r:embed="rId3"/>
+          <a:stretch>
+            <a:fillRect/>
+          </a:stretch>
+        </p:blipFill>
+        <p:spPr>
+          <a:xfrm>
+            <a:off x="10311003" y="3841623"/>
+            <a:ext cx="729234" cy="729234"/>
+          </a:xfrm>
+          <a:prstGeom prst="rect">
+            <a:avLst/>
+          </a:prstGeom>
+        </p:spPr>
+      </p:pic>
+      <p:pic>
+        <p:nvPicPr>
+          <p:cNvPr id="34" name="Image 2" descr="/home/user/nestro/cementing_2025_2026/build/assets/gradline.png">    </p:cNvPr>
+          <p:cNvPicPr>
+            <a:picLocks noChangeAspect="1"/>
+          </p:cNvPicPr>
+          <p:nvPr/>
+        </p:nvPicPr>
+        <p:blipFill>
+          <a:blip r:embed="rId4"/>
+          <a:stretch>
+            <a:fillRect/>
+          </a:stretch>
+        </p:blipFill>
+        <p:spPr>
+          <a:xfrm>
             <a:off x="914400" y="6053328"/>
             <a:ext cx="10332720" cy="45720"/>
           </a:xfrm>
@@ -2350,6 +2549,9 @@
   <p:clrMapOvr>
     <a:masterClrMapping/>
   </p:clrMapOvr>
+  <p:transition spd="med">
+    <p:push dir="l"/>
+  </p:transition>
 </p:sld>
 </file>
 
@@ -2459,7 +2661,7 @@
         </p:nvSpPr>
         <p:spPr>
           <a:xfrm>
-            <a:off x="10287000" y="1170432"/>
+            <a:off x="9921240" y="1179576"/>
             <a:ext cx="100584" cy="100584"/>
           </a:xfrm>
           <a:prstGeom prst="ellipse">
@@ -2484,7 +2686,7 @@
         </p:nvSpPr>
         <p:spPr>
           <a:xfrm>
-            <a:off x="10460736" y="1170432"/>
+            <a:off x="10094976" y="1179576"/>
             <a:ext cx="347472" cy="100584"/>
           </a:xfrm>
           <a:prstGeom prst="roundRect">
@@ -2511,7 +2713,7 @@
         </p:nvSpPr>
         <p:spPr>
           <a:xfrm>
-            <a:off x="10881360" y="1170432"/>
+            <a:off x="10515600" y="1179576"/>
             <a:ext cx="777240" cy="100584"/>
           </a:xfrm>
           <a:prstGeom prst="roundRect">
@@ -3521,6 +3723,9 @@
   <p:clrMapOvr>
     <a:masterClrMapping/>
   </p:clrMapOvr>
+  <p:transition spd="med">
+    <p:push dir="l"/>
+  </p:transition>
 </p:sld>
 </file>
 
@@ -3630,7 +3835,7 @@
         </p:nvSpPr>
         <p:spPr>
           <a:xfrm>
-            <a:off x="10287000" y="1170432"/>
+            <a:off x="9921240" y="1179576"/>
             <a:ext cx="100584" cy="100584"/>
           </a:xfrm>
           <a:prstGeom prst="ellipse">
@@ -3655,7 +3860,7 @@
         </p:nvSpPr>
         <p:spPr>
           <a:xfrm>
-            <a:off x="10460736" y="1170432"/>
+            <a:off x="10094976" y="1179576"/>
             <a:ext cx="347472" cy="100584"/>
           </a:xfrm>
           <a:prstGeom prst="roundRect">
@@ -3682,7 +3887,7 @@
         </p:nvSpPr>
         <p:spPr>
           <a:xfrm>
-            <a:off x="10881360" y="1170432"/>
+            <a:off x="10515600" y="1179576"/>
             <a:ext cx="777240" cy="100584"/>
           </a:xfrm>
           <a:prstGeom prst="roundRect">
@@ -5796,6 +6001,9 @@
   <p:clrMapOvr>
     <a:masterClrMapping/>
   </p:clrMapOvr>
+  <p:transition spd="med">
+    <p:push dir="l"/>
+  </p:transition>
 </p:sld>
 </file>
 
@@ -5905,7 +6113,7 @@
         </p:nvSpPr>
         <p:spPr>
           <a:xfrm>
-            <a:off x="10287000" y="1170432"/>
+            <a:off x="9921240" y="1179576"/>
             <a:ext cx="100584" cy="100584"/>
           </a:xfrm>
           <a:prstGeom prst="ellipse">
@@ -5930,7 +6138,7 @@
         </p:nvSpPr>
         <p:spPr>
           <a:xfrm>
-            <a:off x="10460736" y="1170432"/>
+            <a:off x="10094976" y="1179576"/>
             <a:ext cx="347472" cy="100584"/>
           </a:xfrm>
           <a:prstGeom prst="roundRect">
@@ -5957,7 +6165,7 @@
         </p:nvSpPr>
         <p:spPr>
           <a:xfrm>
-            <a:off x="10881360" y="1170432"/>
+            <a:off x="10515600" y="1179576"/>
             <a:ext cx="777240" cy="100584"/>
           </a:xfrm>
           <a:prstGeom prst="roundRect">
@@ -6807,7 +7015,7 @@
       </p:sp>
       <p:pic>
         <p:nvPicPr>
-          <p:cNvPr id="28" name="Image 1" descr="/tmp/claude-0/-home-user-nestro/911a244d-2256-5cb1-aca9-58afdd2ea567/scratchpad/build/assets/vgrad.png">    </p:cNvPr>
+          <p:cNvPr id="28" name="Image 1" descr="/home/user/nestro/cementing_2025_2026/build/assets/vgrad.png">    </p:cNvPr>
           <p:cNvPicPr>
             <a:picLocks noChangeAspect="1"/>
           </p:cNvPicPr>
@@ -7346,6 +7554,9 @@
   <p:clrMapOvr>
     <a:masterClrMapping/>
   </p:clrMapOvr>
+  <p:transition spd="med">
+    <p:push dir="l"/>
+  </p:transition>
 </p:sld>
 </file>
 

</xml_diff>